<commit_message>
Fit the workspace change to slide numbering and variants
Rebasing onto master turned up two seams:

slide-numbers.test.ts resolved templates at <install>/templates, which this
branch moved to starter/templates.

It also builds a Presentation with an explicit templateLibrary but no
assetsDir, which the new constructor turned into a hard workspace lookup.
That was stricter than it needed to be: a template library has no sensible
default, but assets do — the engine's own folder, where the bundled icons
already live. Only a missing templateLibrary forces the lookup now, so
`new Presentation({ templateLibrary })` works with no workspace at all.

The example's build report picks up master's variant-group and slides
sections.

Co-Authored-By: Claude Opus 5 <noreply@anthropic.com>
</commit_message>
<xml_diff>
--- a/examples/workspace/projects/how-it-works/output/how-it-works.pptx
+++ b/examples/workspace/projects/how-it-works/output/how-it-works.pptx
@@ -3040,7 +3040,7 @@
       </p:sp>
       <p:sp>
         <p:nvSpPr>
-          <p:cNvPr id="37" name="Text 35"/>
+          <p:cNvPr id="37" name="pptx-gen-page-number"/>
           <p:cNvSpPr/>
           <p:nvPr/>
         </p:nvSpPr>
@@ -3079,7 +3079,7 @@
             <a:pPr indent="0" marL="0">
               <a:buNone/>
             </a:pPr>
-            <a:r>
+            <a:fld id="{2E4665E2-EFF7-470C-8361-9A98E551A7E7}" type="slidenum">
               <a:rPr lang="en-US" sz="700" dirty="0">
                 <a:solidFill>
                   <a:srgbClr val="5B6472"/>
@@ -3089,7 +3089,7 @@
                 <a:cs typeface="Inter" pitchFamily="34" charset="-120"/>
               </a:rPr>
               <a:t>1</a:t>
-            </a:r>
+            </a:fld>
             <a:endParaRPr lang="en-US" sz="700" dirty="0"/>
           </a:p>
         </p:txBody>

</xml_diff>